<commit_message>
defense deck: methodology section rework — new diagrams and 6-column ablation timeline
§02 (Metodología) rebuilt across slides 8-10:
  - slide 8: new CLIP contrastive-matrix diagram (5×5 with real LC25000 patches, encoders between samples and matrix)
  - slide 9: baseline architecture diagram (ResNet50+BERT+CLIP head) + full HP block
  - slide 10: 6-column ablation timeline (RQ2 plain vs CLIP · PLIP zero-shot · RQ3 stain · RQ4 text×prompt grid · RQ5 DINOv2 · RQ5 PLIP) + eval-externa + protocolo detail

§01 (Motivación) polish across slides 3-6:
  - bridging takeaways ("→ Esto convierte...") on slides 3, 4, 6
  - hedged VLM claims on slide 5 (bullet 3 indicative → conditional)
  - sharpened central question on slide 6 (measurable degradation, not mechanism)
  - Spanish-translated diagram labels on slide 5

Speaker notes added to slides 3, 4, 5, 6.

Co-Authored-By: Claude Opus 4.7 <noreply@anthropic.com>
</commit_message>
<xml_diff>
--- a/report/TFM_defense_template.pptx
+++ b/report/TFM_defense_template.pptx
@@ -2728,67 +2728,6 @@
               <a:rPr lang="en-US" smtClean="0"/>
               <a:t>Click to edit Master title style</a:t>
             </a:r>
-            <a:endParaRPr lang="en-US"/>
-          </a:p>
-        </p:txBody>
-      </p:sp>
-      <p:sp>
-        <p:nvSpPr>
-          <p:cNvPr id="3" name="Picture Placeholder 2"/>
-          <p:cNvSpPr>
-            <a:spLocks noGrp="1"/>
-          </p:cNvSpPr>
-          <p:nvPr>
-            <p:ph type="pic" idx="1"/>
-          </p:nvPr>
-        </p:nvSpPr>
-        <p:spPr>
-          <a:xfrm>
-            <a:off x="1792288" y="612775"/>
-            <a:ext cx="5486400" cy="4114800"/>
-          </a:xfrm>
-        </p:spPr>
-        <p:txBody>
-          <a:bodyPr/>
-          <a:lstStyle>
-            <a:lvl1pPr marL="0" indent="0">
-              <a:buNone/>
-              <a:defRPr sz="3200"/>
-            </a:lvl1pPr>
-            <a:lvl2pPr marL="457200" indent="0">
-              <a:buNone/>
-              <a:defRPr sz="2800"/>
-            </a:lvl2pPr>
-            <a:lvl3pPr marL="914400" indent="0">
-              <a:buNone/>
-              <a:defRPr sz="2400"/>
-            </a:lvl3pPr>
-            <a:lvl4pPr marL="1371600" indent="0">
-              <a:buNone/>
-              <a:defRPr sz="2000"/>
-            </a:lvl4pPr>
-            <a:lvl5pPr marL="1828800" indent="0">
-              <a:buNone/>
-              <a:defRPr sz="2000"/>
-            </a:lvl5pPr>
-            <a:lvl6pPr marL="2286000" indent="0">
-              <a:buNone/>
-              <a:defRPr sz="2000"/>
-            </a:lvl6pPr>
-            <a:lvl7pPr marL="2743200" indent="0">
-              <a:buNone/>
-              <a:defRPr sz="2000"/>
-            </a:lvl7pPr>
-            <a:lvl8pPr marL="3200400" indent="0">
-              <a:buNone/>
-              <a:defRPr sz="2000"/>
-            </a:lvl8pPr>
-            <a:lvl9pPr marL="3657600" indent="0">
-              <a:buNone/>
-              <a:defRPr sz="2000"/>
-            </a:lvl9pPr>
-          </a:lstStyle>
-          <a:p>
             <a:endParaRPr lang="en-US"/>
           </a:p>
         </p:txBody>

</xml_diff>